<commit_message>
chore: Update Rangkuman Cepat (Menambahkan UseCase Diagram Menggunakan mermaid.live)
</commit_message>
<xml_diff>
--- a/Rangkuman Cepat.pptx
+++ b/Rangkuman Cepat.pptx
@@ -5,7 +5,7 @@
     <p:sldMasterId id="2147483659" r:id="rId1"/>
   </p:sldMasterIdLst>
   <p:notesMasterIdLst>
-    <p:notesMasterId r:id="rId15"/>
+    <p:notesMasterId r:id="rId18"/>
   </p:notesMasterIdLst>
   <p:sldIdLst>
     <p:sldId id="256" r:id="rId2"/>
@@ -21,20 +21,23 @@
     <p:sldId id="283" r:id="rId12"/>
     <p:sldId id="286" r:id="rId13"/>
     <p:sldId id="285" r:id="rId14"/>
+    <p:sldId id="289" r:id="rId15"/>
+    <p:sldId id="288" r:id="rId16"/>
+    <p:sldId id="287" r:id="rId17"/>
   </p:sldIdLst>
   <p:sldSz cx="18288000" cy="10287000"/>
   <p:notesSz cx="6858000" cy="9144000"/>
   <p:embeddedFontLst>
     <p:embeddedFont>
       <p:font typeface="Barlow" panose="00000500000000000000" pitchFamily="2" charset="0"/>
-      <p:regular r:id="rId16"/>
-      <p:bold r:id="rId17"/>
-      <p:italic r:id="rId18"/>
-      <p:boldItalic r:id="rId19"/>
+      <p:regular r:id="rId19"/>
+      <p:bold r:id="rId20"/>
+      <p:italic r:id="rId21"/>
+      <p:boldItalic r:id="rId22"/>
     </p:embeddedFont>
     <p:embeddedFont>
       <p:font typeface="Concert One" pitchFamily="2" charset="0"/>
-      <p:regular r:id="rId20"/>
+      <p:regular r:id="rId23"/>
     </p:embeddedFont>
   </p:embeddedFontLst>
   <p:defaultTextStyle>
@@ -1329,6 +1332,260 @@
     <p:extLst>
       <p:ext uri="{BB962C8B-B14F-4D97-AF65-F5344CB8AC3E}">
         <p14:creationId xmlns:p14="http://schemas.microsoft.com/office/powerpoint/2010/main" val="3258754486"/>
+      </p:ext>
+    </p:extLst>
+  </p:cSld>
+  <p:clrMapOvr>
+    <a:masterClrMapping/>
+  </p:clrMapOvr>
+</p:notes>
+</file>
+
+<file path=ppt/notesSlides/notesSlide14.xml><?xml version="1.0" encoding="utf-8"?>
+<p:notes xmlns:a="http://schemas.openxmlformats.org/drawingml/2006/main" xmlns:r="http://schemas.openxmlformats.org/officeDocument/2006/relationships" xmlns:p="http://schemas.openxmlformats.org/presentationml/2006/main" showMasterSp="0" showMasterPhAnim="0">
+  <p:cSld>
+    <p:spTree>
+      <p:nvGrpSpPr>
+        <p:cNvPr id="1" name="Shape 147">
+          <a:extLst>
+            <a:ext uri="{FF2B5EF4-FFF2-40B4-BE49-F238E27FC236}">
+              <a16:creationId xmlns:a16="http://schemas.microsoft.com/office/drawing/2014/main" id="{14355ADC-3FC8-6A58-1486-3E52E12D4DAA}"/>
+            </a:ext>
+          </a:extLst>
+        </p:cNvPr>
+        <p:cNvGrpSpPr/>
+        <p:nvPr/>
+      </p:nvGrpSpPr>
+      <p:grpSpPr>
+        <a:xfrm>
+          <a:off x="0" y="0"/>
+          <a:ext cx="0" cy="0"/>
+          <a:chOff x="0" y="0"/>
+          <a:chExt cx="0" cy="0"/>
+        </a:xfrm>
+      </p:grpSpPr>
+      <p:sp>
+        <p:nvSpPr>
+          <p:cNvPr id="148" name="Google Shape;148;p1:notes">
+            <a:extLst>
+              <a:ext uri="{FF2B5EF4-FFF2-40B4-BE49-F238E27FC236}">
+                <a16:creationId xmlns:a16="http://schemas.microsoft.com/office/drawing/2014/main" id="{14318576-1C60-7D26-D138-C67E796FD56D}"/>
+              </a:ext>
+            </a:extLst>
+          </p:cNvPr>
+          <p:cNvSpPr txBox="1">
+            <a:spLocks noGrp="1"/>
+          </p:cNvSpPr>
+          <p:nvPr>
+            <p:ph type="body" idx="1"/>
+          </p:nvPr>
+        </p:nvSpPr>
+        <p:spPr>
+          <a:xfrm>
+            <a:off x="685800" y="4343400"/>
+            <a:ext cx="5486400" cy="4114800"/>
+          </a:xfrm>
+          <a:prstGeom prst="rect">
+            <a:avLst/>
+          </a:prstGeom>
+        </p:spPr>
+        <p:txBody>
+          <a:bodyPr spcFirstLastPara="1" wrap="square" lIns="91425" tIns="91425" rIns="91425" bIns="91425" anchor="t" anchorCtr="0">
+            <a:noAutofit/>
+          </a:bodyPr>
+          <a:lstStyle/>
+          <a:p>
+            <a:pPr marL="0" lvl="0" indent="0" algn="l" rtl="0">
+              <a:spcBef>
+                <a:spcPts val="0"/>
+              </a:spcBef>
+              <a:spcAft>
+                <a:spcPts val="0"/>
+              </a:spcAft>
+              <a:buNone/>
+            </a:pPr>
+            <a:endParaRPr/>
+          </a:p>
+        </p:txBody>
+      </p:sp>
+      <p:sp>
+        <p:nvSpPr>
+          <p:cNvPr id="149" name="Google Shape;149;p1:notes">
+            <a:extLst>
+              <a:ext uri="{FF2B5EF4-FFF2-40B4-BE49-F238E27FC236}">
+                <a16:creationId xmlns:a16="http://schemas.microsoft.com/office/drawing/2014/main" id="{5DAF307A-D4C1-91AF-A9DA-A21751CFFBCC}"/>
+              </a:ext>
+            </a:extLst>
+          </p:cNvPr>
+          <p:cNvSpPr>
+            <a:spLocks noGrp="1" noRot="1" noChangeAspect="1"/>
+          </p:cNvSpPr>
+          <p:nvPr>
+            <p:ph type="sldImg" idx="2"/>
+          </p:nvPr>
+        </p:nvSpPr>
+        <p:spPr>
+          <a:xfrm>
+            <a:off x="381000" y="685800"/>
+            <a:ext cx="6096000" cy="3429000"/>
+          </a:xfrm>
+          <a:custGeom>
+            <a:avLst/>
+            <a:gdLst/>
+            <a:ahLst/>
+            <a:cxnLst/>
+            <a:rect l="l" t="t" r="r" b="b"/>
+            <a:pathLst>
+              <a:path w="120000" h="120000" extrusionOk="0">
+                <a:moveTo>
+                  <a:pt x="0" y="0"/>
+                </a:moveTo>
+                <a:lnTo>
+                  <a:pt x="120000" y="0"/>
+                </a:lnTo>
+                <a:lnTo>
+                  <a:pt x="120000" y="120000"/>
+                </a:lnTo>
+                <a:lnTo>
+                  <a:pt x="0" y="120000"/>
+                </a:lnTo>
+                <a:close/>
+              </a:path>
+            </a:pathLst>
+          </a:custGeom>
+        </p:spPr>
+      </p:sp>
+    </p:spTree>
+    <p:extLst>
+      <p:ext uri="{BB962C8B-B14F-4D97-AF65-F5344CB8AC3E}">
+        <p14:creationId xmlns:p14="http://schemas.microsoft.com/office/powerpoint/2010/main" val="12051535"/>
+      </p:ext>
+    </p:extLst>
+  </p:cSld>
+  <p:clrMapOvr>
+    <a:masterClrMapping/>
+  </p:clrMapOvr>
+</p:notes>
+</file>
+
+<file path=ppt/notesSlides/notesSlide15.xml><?xml version="1.0" encoding="utf-8"?>
+<p:notes xmlns:a="http://schemas.openxmlformats.org/drawingml/2006/main" xmlns:r="http://schemas.openxmlformats.org/officeDocument/2006/relationships" xmlns:p="http://schemas.openxmlformats.org/presentationml/2006/main" showMasterSp="0" showMasterPhAnim="0">
+  <p:cSld>
+    <p:spTree>
+      <p:nvGrpSpPr>
+        <p:cNvPr id="1" name="Shape 325">
+          <a:extLst>
+            <a:ext uri="{FF2B5EF4-FFF2-40B4-BE49-F238E27FC236}">
+              <a16:creationId xmlns:a16="http://schemas.microsoft.com/office/drawing/2014/main" id="{ECE8571E-E874-EBB3-608D-F18A50AAADEF}"/>
+            </a:ext>
+          </a:extLst>
+        </p:cNvPr>
+        <p:cNvGrpSpPr/>
+        <p:nvPr/>
+      </p:nvGrpSpPr>
+      <p:grpSpPr>
+        <a:xfrm>
+          <a:off x="0" y="0"/>
+          <a:ext cx="0" cy="0"/>
+          <a:chOff x="0" y="0"/>
+          <a:chExt cx="0" cy="0"/>
+        </a:xfrm>
+      </p:grpSpPr>
+      <p:sp>
+        <p:nvSpPr>
+          <p:cNvPr id="326" name="Google Shape;326;p7:notes">
+            <a:extLst>
+              <a:ext uri="{FF2B5EF4-FFF2-40B4-BE49-F238E27FC236}">
+                <a16:creationId xmlns:a16="http://schemas.microsoft.com/office/drawing/2014/main" id="{4A16D14D-1CFC-DE3F-1ABA-18D968640257}"/>
+              </a:ext>
+            </a:extLst>
+          </p:cNvPr>
+          <p:cNvSpPr txBox="1">
+            <a:spLocks noGrp="1"/>
+          </p:cNvSpPr>
+          <p:nvPr>
+            <p:ph type="body" idx="1"/>
+          </p:nvPr>
+        </p:nvSpPr>
+        <p:spPr>
+          <a:xfrm>
+            <a:off x="685800" y="4343400"/>
+            <a:ext cx="5486400" cy="4114800"/>
+          </a:xfrm>
+          <a:prstGeom prst="rect">
+            <a:avLst/>
+          </a:prstGeom>
+        </p:spPr>
+        <p:txBody>
+          <a:bodyPr spcFirstLastPara="1" wrap="square" lIns="91425" tIns="91425" rIns="91425" bIns="91425" anchor="t" anchorCtr="0">
+            <a:noAutofit/>
+          </a:bodyPr>
+          <a:lstStyle/>
+          <a:p>
+            <a:pPr marL="0" lvl="0" indent="0" algn="l" rtl="0">
+              <a:spcBef>
+                <a:spcPts val="0"/>
+              </a:spcBef>
+              <a:spcAft>
+                <a:spcPts val="0"/>
+              </a:spcAft>
+              <a:buNone/>
+            </a:pPr>
+            <a:endParaRPr/>
+          </a:p>
+        </p:txBody>
+      </p:sp>
+      <p:sp>
+        <p:nvSpPr>
+          <p:cNvPr id="327" name="Google Shape;327;p7:notes">
+            <a:extLst>
+              <a:ext uri="{FF2B5EF4-FFF2-40B4-BE49-F238E27FC236}">
+                <a16:creationId xmlns:a16="http://schemas.microsoft.com/office/drawing/2014/main" id="{F1E58C39-D094-F36B-23B0-10E168323A41}"/>
+              </a:ext>
+            </a:extLst>
+          </p:cNvPr>
+          <p:cNvSpPr>
+            <a:spLocks noGrp="1" noRot="1" noChangeAspect="1"/>
+          </p:cNvSpPr>
+          <p:nvPr>
+            <p:ph type="sldImg" idx="2"/>
+          </p:nvPr>
+        </p:nvSpPr>
+        <p:spPr>
+          <a:xfrm>
+            <a:off x="381000" y="685800"/>
+            <a:ext cx="6096000" cy="3429000"/>
+          </a:xfrm>
+          <a:custGeom>
+            <a:avLst/>
+            <a:gdLst/>
+            <a:ahLst/>
+            <a:cxnLst/>
+            <a:rect l="l" t="t" r="r" b="b"/>
+            <a:pathLst>
+              <a:path w="120000" h="120000" extrusionOk="0">
+                <a:moveTo>
+                  <a:pt x="0" y="0"/>
+                </a:moveTo>
+                <a:lnTo>
+                  <a:pt x="120000" y="0"/>
+                </a:lnTo>
+                <a:lnTo>
+                  <a:pt x="120000" y="120000"/>
+                </a:lnTo>
+                <a:lnTo>
+                  <a:pt x="0" y="120000"/>
+                </a:lnTo>
+                <a:close/>
+              </a:path>
+            </a:pathLst>
+          </a:custGeom>
+        </p:spPr>
+      </p:sp>
+    </p:spTree>
+    <p:extLst>
+      <p:ext uri="{BB962C8B-B14F-4D97-AF65-F5344CB8AC3E}">
+        <p14:creationId xmlns:p14="http://schemas.microsoft.com/office/powerpoint/2010/main" val="1311384261"/>
       </p:ext>
     </p:extLst>
   </p:cSld>
@@ -16722,6 +16979,1154 @@
     <p:extLst>
       <p:ext uri="{BB962C8B-B14F-4D97-AF65-F5344CB8AC3E}">
         <p14:creationId xmlns:p14="http://schemas.microsoft.com/office/powerpoint/2010/main" val="864565744"/>
+      </p:ext>
+    </p:extLst>
+  </p:cSld>
+  <p:clrMapOvr>
+    <a:masterClrMapping/>
+  </p:clrMapOvr>
+</p:sld>
+</file>
+
+<file path=ppt/slides/slide14.xml><?xml version="1.0" encoding="utf-8"?>
+<p:sld xmlns:a="http://schemas.openxmlformats.org/drawingml/2006/main" xmlns:r="http://schemas.openxmlformats.org/officeDocument/2006/relationships" xmlns:p="http://schemas.openxmlformats.org/presentationml/2006/main">
+  <p:cSld>
+    <p:bg>
+      <p:bgPr>
+        <a:solidFill>
+          <a:srgbClr val="7FDAFF"/>
+        </a:solidFill>
+        <a:effectLst/>
+      </p:bgPr>
+    </p:bg>
+    <p:spTree>
+      <p:nvGrpSpPr>
+        <p:cNvPr id="1" name="Shape 150">
+          <a:extLst>
+            <a:ext uri="{FF2B5EF4-FFF2-40B4-BE49-F238E27FC236}">
+              <a16:creationId xmlns:a16="http://schemas.microsoft.com/office/drawing/2014/main" id="{F6D10FF4-CB5A-E222-81C6-C20D3E148B06}"/>
+            </a:ext>
+          </a:extLst>
+        </p:cNvPr>
+        <p:cNvGrpSpPr/>
+        <p:nvPr/>
+      </p:nvGrpSpPr>
+      <p:grpSpPr>
+        <a:xfrm>
+          <a:off x="0" y="0"/>
+          <a:ext cx="0" cy="0"/>
+          <a:chOff x="0" y="0"/>
+          <a:chExt cx="0" cy="0"/>
+        </a:xfrm>
+      </p:grpSpPr>
+      <p:grpSp>
+        <p:nvGrpSpPr>
+          <p:cNvPr id="151" name="Google Shape;151;p13">
+            <a:extLst>
+              <a:ext uri="{FF2B5EF4-FFF2-40B4-BE49-F238E27FC236}">
+                <a16:creationId xmlns:a16="http://schemas.microsoft.com/office/drawing/2014/main" id="{8A5A8C49-2B78-5B61-E5C1-CBF09146CF5A}"/>
+              </a:ext>
+            </a:extLst>
+          </p:cNvPr>
+          <p:cNvGrpSpPr/>
+          <p:nvPr/>
+        </p:nvGrpSpPr>
+        <p:grpSpPr>
+          <a:xfrm>
+            <a:off x="577516" y="3200777"/>
+            <a:ext cx="16681784" cy="4087839"/>
+            <a:chOff x="0" y="-47625"/>
+            <a:chExt cx="2325925" cy="1171615"/>
+          </a:xfrm>
+        </p:grpSpPr>
+        <p:sp>
+          <p:nvSpPr>
+            <p:cNvPr id="152" name="Google Shape;152;p13">
+              <a:extLst>
+                <a:ext uri="{FF2B5EF4-FFF2-40B4-BE49-F238E27FC236}">
+                  <a16:creationId xmlns:a16="http://schemas.microsoft.com/office/drawing/2014/main" id="{064BDA72-D7F7-AE7D-7DA7-EA8104BF81BD}"/>
+                </a:ext>
+              </a:extLst>
+            </p:cNvPr>
+            <p:cNvSpPr/>
+            <p:nvPr/>
+          </p:nvSpPr>
+          <p:spPr>
+            <a:xfrm>
+              <a:off x="0" y="0"/>
+              <a:ext cx="2325925" cy="1123990"/>
+            </a:xfrm>
+            <a:custGeom>
+              <a:avLst/>
+              <a:gdLst/>
+              <a:ahLst/>
+              <a:cxnLst/>
+              <a:rect l="l" t="t" r="r" b="b"/>
+              <a:pathLst>
+                <a:path w="2325925" h="1123990" extrusionOk="0">
+                  <a:moveTo>
+                    <a:pt x="28620" y="0"/>
+                  </a:moveTo>
+                  <a:lnTo>
+                    <a:pt x="2297305" y="0"/>
+                  </a:lnTo>
+                  <a:cubicBezTo>
+                    <a:pt x="2313111" y="0"/>
+                    <a:pt x="2325925" y="12813"/>
+                    <a:pt x="2325925" y="28620"/>
+                  </a:cubicBezTo>
+                  <a:lnTo>
+                    <a:pt x="2325925" y="1095370"/>
+                  </a:lnTo>
+                  <a:cubicBezTo>
+                    <a:pt x="2325925" y="1111176"/>
+                    <a:pt x="2313111" y="1123990"/>
+                    <a:pt x="2297305" y="1123990"/>
+                  </a:cubicBezTo>
+                  <a:lnTo>
+                    <a:pt x="28620" y="1123990"/>
+                  </a:lnTo>
+                  <a:cubicBezTo>
+                    <a:pt x="12813" y="1123990"/>
+                    <a:pt x="0" y="1111176"/>
+                    <a:pt x="0" y="1095370"/>
+                  </a:cubicBezTo>
+                  <a:lnTo>
+                    <a:pt x="0" y="28620"/>
+                  </a:lnTo>
+                  <a:cubicBezTo>
+                    <a:pt x="0" y="12813"/>
+                    <a:pt x="12813" y="0"/>
+                    <a:pt x="28620" y="0"/>
+                  </a:cubicBezTo>
+                  <a:close/>
+                </a:path>
+              </a:pathLst>
+            </a:custGeom>
+            <a:solidFill>
+              <a:srgbClr val="FFFFFF"/>
+            </a:solidFill>
+            <a:ln w="85725" cap="rnd" cmpd="sng">
+              <a:solidFill>
+                <a:srgbClr val="000000"/>
+              </a:solidFill>
+              <a:prstDash val="solid"/>
+              <a:round/>
+              <a:headEnd type="none" w="sm" len="sm"/>
+              <a:tailEnd type="none" w="sm" len="sm"/>
+            </a:ln>
+          </p:spPr>
+          <p:txBody>
+            <a:bodyPr spcFirstLastPara="1" wrap="square" lIns="91425" tIns="91425" rIns="91425" bIns="91425" anchor="ctr" anchorCtr="0">
+              <a:noAutofit/>
+            </a:bodyPr>
+            <a:lstStyle/>
+            <a:p>
+              <a:pPr marL="0" lvl="0" indent="0" algn="l" rtl="0">
+                <a:spcBef>
+                  <a:spcPts val="0"/>
+                </a:spcBef>
+                <a:spcAft>
+                  <a:spcPts val="0"/>
+                </a:spcAft>
+                <a:buNone/>
+              </a:pPr>
+              <a:endParaRPr/>
+            </a:p>
+          </p:txBody>
+        </p:sp>
+        <p:sp>
+          <p:nvSpPr>
+            <p:cNvPr id="153" name="Google Shape;153;p13">
+              <a:extLst>
+                <a:ext uri="{FF2B5EF4-FFF2-40B4-BE49-F238E27FC236}">
+                  <a16:creationId xmlns:a16="http://schemas.microsoft.com/office/drawing/2014/main" id="{8DE654B3-8827-0A31-6C36-FEE5684B3DEC}"/>
+                </a:ext>
+              </a:extLst>
+            </p:cNvPr>
+            <p:cNvSpPr txBox="1"/>
+            <p:nvPr/>
+          </p:nvSpPr>
+          <p:spPr>
+            <a:xfrm>
+              <a:off x="0" y="-47625"/>
+              <a:ext cx="2325925" cy="1171615"/>
+            </a:xfrm>
+            <a:prstGeom prst="rect">
+              <a:avLst/>
+            </a:prstGeom>
+            <a:noFill/>
+            <a:ln>
+              <a:noFill/>
+            </a:ln>
+          </p:spPr>
+          <p:txBody>
+            <a:bodyPr spcFirstLastPara="1" wrap="square" lIns="50800" tIns="50800" rIns="50800" bIns="50800" anchor="ctr" anchorCtr="0">
+              <a:noAutofit/>
+            </a:bodyPr>
+            <a:lstStyle/>
+            <a:p>
+              <a:pPr marL="0" marR="0" lvl="0" indent="0" algn="ctr" rtl="0">
+                <a:lnSpc>
+                  <a:spcPct val="186611"/>
+                </a:lnSpc>
+                <a:spcBef>
+                  <a:spcPts val="0"/>
+                </a:spcBef>
+                <a:spcAft>
+                  <a:spcPts val="0"/>
+                </a:spcAft>
+                <a:buNone/>
+              </a:pPr>
+              <a:endParaRPr sz="1800" b="0" i="0" u="none" strike="noStrike" cap="none">
+                <a:solidFill>
+                  <a:schemeClr val="dk1"/>
+                </a:solidFill>
+                <a:latin typeface="Calibri"/>
+                <a:ea typeface="Calibri"/>
+                <a:cs typeface="Calibri"/>
+                <a:sym typeface="Calibri"/>
+              </a:endParaRPr>
+            </a:p>
+          </p:txBody>
+        </p:sp>
+      </p:grpSp>
+      <p:grpSp>
+        <p:nvGrpSpPr>
+          <p:cNvPr id="154" name="Google Shape;154;p13">
+            <a:extLst>
+              <a:ext uri="{FF2B5EF4-FFF2-40B4-BE49-F238E27FC236}">
+                <a16:creationId xmlns:a16="http://schemas.microsoft.com/office/drawing/2014/main" id="{F79DA5A0-931A-78D4-D20B-CC6211A06A91}"/>
+              </a:ext>
+            </a:extLst>
+          </p:cNvPr>
+          <p:cNvGrpSpPr/>
+          <p:nvPr/>
+        </p:nvGrpSpPr>
+        <p:grpSpPr>
+          <a:xfrm>
+            <a:off x="4860758" y="1463482"/>
+            <a:ext cx="8115300" cy="1723961"/>
+            <a:chOff x="0" y="-47625"/>
+            <a:chExt cx="2325925" cy="494104"/>
+          </a:xfrm>
+        </p:grpSpPr>
+        <p:sp>
+          <p:nvSpPr>
+            <p:cNvPr id="155" name="Google Shape;155;p13">
+              <a:extLst>
+                <a:ext uri="{FF2B5EF4-FFF2-40B4-BE49-F238E27FC236}">
+                  <a16:creationId xmlns:a16="http://schemas.microsoft.com/office/drawing/2014/main" id="{887C149A-7B87-1EA4-46AF-A4B0A13FF71F}"/>
+                </a:ext>
+              </a:extLst>
+            </p:cNvPr>
+            <p:cNvSpPr/>
+            <p:nvPr/>
+          </p:nvSpPr>
+          <p:spPr>
+            <a:xfrm>
+              <a:off x="0" y="0"/>
+              <a:ext cx="2325925" cy="446479"/>
+            </a:xfrm>
+            <a:custGeom>
+              <a:avLst/>
+              <a:gdLst/>
+              <a:ahLst/>
+              <a:cxnLst/>
+              <a:rect l="l" t="t" r="r" b="b"/>
+              <a:pathLst>
+                <a:path w="2325925" h="446479" extrusionOk="0">
+                  <a:moveTo>
+                    <a:pt x="28620" y="0"/>
+                  </a:moveTo>
+                  <a:lnTo>
+                    <a:pt x="2297305" y="0"/>
+                  </a:lnTo>
+                  <a:cubicBezTo>
+                    <a:pt x="2313111" y="0"/>
+                    <a:pt x="2325925" y="12813"/>
+                    <a:pt x="2325925" y="28620"/>
+                  </a:cubicBezTo>
+                  <a:lnTo>
+                    <a:pt x="2325925" y="417859"/>
+                  </a:lnTo>
+                  <a:cubicBezTo>
+                    <a:pt x="2325925" y="433666"/>
+                    <a:pt x="2313111" y="446479"/>
+                    <a:pt x="2297305" y="446479"/>
+                  </a:cubicBezTo>
+                  <a:lnTo>
+                    <a:pt x="28620" y="446479"/>
+                  </a:lnTo>
+                  <a:cubicBezTo>
+                    <a:pt x="12813" y="446479"/>
+                    <a:pt x="0" y="433666"/>
+                    <a:pt x="0" y="417859"/>
+                  </a:cubicBezTo>
+                  <a:lnTo>
+                    <a:pt x="0" y="28620"/>
+                  </a:lnTo>
+                  <a:cubicBezTo>
+                    <a:pt x="0" y="12813"/>
+                    <a:pt x="12813" y="0"/>
+                    <a:pt x="28620" y="0"/>
+                  </a:cubicBezTo>
+                  <a:close/>
+                </a:path>
+              </a:pathLst>
+            </a:custGeom>
+            <a:solidFill>
+              <a:srgbClr val="FF6F61"/>
+            </a:solidFill>
+            <a:ln w="85725" cap="rnd" cmpd="sng">
+              <a:solidFill>
+                <a:srgbClr val="000000"/>
+              </a:solidFill>
+              <a:prstDash val="solid"/>
+              <a:round/>
+              <a:headEnd type="none" w="sm" len="sm"/>
+              <a:tailEnd type="none" w="sm" len="sm"/>
+            </a:ln>
+          </p:spPr>
+          <p:txBody>
+            <a:bodyPr spcFirstLastPara="1" wrap="square" lIns="91425" tIns="91425" rIns="91425" bIns="91425" anchor="ctr" anchorCtr="0">
+              <a:noAutofit/>
+            </a:bodyPr>
+            <a:lstStyle/>
+            <a:p>
+              <a:pPr marL="0" lvl="0" indent="0" algn="l" rtl="0">
+                <a:spcBef>
+                  <a:spcPts val="0"/>
+                </a:spcBef>
+                <a:spcAft>
+                  <a:spcPts val="0"/>
+                </a:spcAft>
+                <a:buNone/>
+              </a:pPr>
+              <a:endParaRPr/>
+            </a:p>
+          </p:txBody>
+        </p:sp>
+        <p:sp>
+          <p:nvSpPr>
+            <p:cNvPr id="156" name="Google Shape;156;p13">
+              <a:extLst>
+                <a:ext uri="{FF2B5EF4-FFF2-40B4-BE49-F238E27FC236}">
+                  <a16:creationId xmlns:a16="http://schemas.microsoft.com/office/drawing/2014/main" id="{44810C36-8201-7A71-D242-230E3ABE161D}"/>
+                </a:ext>
+              </a:extLst>
+            </p:cNvPr>
+            <p:cNvSpPr txBox="1"/>
+            <p:nvPr/>
+          </p:nvSpPr>
+          <p:spPr>
+            <a:xfrm>
+              <a:off x="0" y="-47625"/>
+              <a:ext cx="2325925" cy="494104"/>
+            </a:xfrm>
+            <a:prstGeom prst="rect">
+              <a:avLst/>
+            </a:prstGeom>
+            <a:noFill/>
+            <a:ln>
+              <a:noFill/>
+            </a:ln>
+          </p:spPr>
+          <p:txBody>
+            <a:bodyPr spcFirstLastPara="1" wrap="square" lIns="50800" tIns="50800" rIns="50800" bIns="50800" anchor="ctr" anchorCtr="0">
+              <a:noAutofit/>
+            </a:bodyPr>
+            <a:lstStyle/>
+            <a:p>
+              <a:pPr marL="0" marR="0" lvl="0" indent="0" algn="ctr" rtl="0">
+                <a:lnSpc>
+                  <a:spcPct val="186611"/>
+                </a:lnSpc>
+                <a:spcBef>
+                  <a:spcPts val="0"/>
+                </a:spcBef>
+                <a:spcAft>
+                  <a:spcPts val="0"/>
+                </a:spcAft>
+                <a:buNone/>
+              </a:pPr>
+              <a:endParaRPr sz="1800" b="0" i="0" u="none" strike="noStrike" cap="none">
+                <a:solidFill>
+                  <a:schemeClr val="dk1"/>
+                </a:solidFill>
+                <a:latin typeface="Calibri"/>
+                <a:ea typeface="Calibri"/>
+                <a:cs typeface="Calibri"/>
+                <a:sym typeface="Calibri"/>
+              </a:endParaRPr>
+            </a:p>
+          </p:txBody>
+        </p:sp>
+      </p:grpSp>
+      <p:sp>
+        <p:nvSpPr>
+          <p:cNvPr id="165" name="Google Shape;165;p13">
+            <a:extLst>
+              <a:ext uri="{FF2B5EF4-FFF2-40B4-BE49-F238E27FC236}">
+                <a16:creationId xmlns:a16="http://schemas.microsoft.com/office/drawing/2014/main" id="{6922F027-2A72-A8C4-AFC8-E504A0FD647E}"/>
+              </a:ext>
+            </a:extLst>
+          </p:cNvPr>
+          <p:cNvSpPr txBox="1"/>
+          <p:nvPr/>
+        </p:nvSpPr>
+        <p:spPr>
+          <a:xfrm>
+            <a:off x="903314" y="4496783"/>
+            <a:ext cx="16030188" cy="1661993"/>
+          </a:xfrm>
+          <a:prstGeom prst="rect">
+            <a:avLst/>
+          </a:prstGeom>
+          <a:noFill/>
+          <a:ln>
+            <a:noFill/>
+          </a:ln>
+        </p:spPr>
+        <p:txBody>
+          <a:bodyPr spcFirstLastPara="1" wrap="square" lIns="0" tIns="0" rIns="0" bIns="0" anchor="t" anchorCtr="0">
+            <a:spAutoFit/>
+          </a:bodyPr>
+          <a:lstStyle/>
+          <a:p>
+            <a:pPr marL="0" marR="0" lvl="0" indent="0" algn="ctr" rtl="0">
+              <a:lnSpc>
+                <a:spcPct val="100000"/>
+              </a:lnSpc>
+              <a:spcBef>
+                <a:spcPts val="0"/>
+              </a:spcBef>
+              <a:spcAft>
+                <a:spcPts val="0"/>
+              </a:spcAft>
+              <a:buNone/>
+            </a:pPr>
+            <a:r>
+              <a:rPr lang="en-US" sz="5400" b="1" i="0" u="none" strike="noStrike" cap="none" dirty="0">
+                <a:solidFill>
+                  <a:srgbClr val="000000"/>
+                </a:solidFill>
+                <a:latin typeface="Concert One"/>
+                <a:ea typeface="Concert One"/>
+                <a:cs typeface="Concert One"/>
+                <a:sym typeface="Concert One"/>
+              </a:rPr>
+              <a:t>Use Case Diagram = </a:t>
+            </a:r>
+            <a:r>
+              <a:rPr lang="en-US" sz="5400" b="1" i="0" u="none" strike="noStrike" cap="none" dirty="0" err="1">
+                <a:solidFill>
+                  <a:srgbClr val="000000"/>
+                </a:solidFill>
+                <a:latin typeface="Concert One"/>
+                <a:ea typeface="Concert One"/>
+                <a:cs typeface="Concert One"/>
+                <a:sym typeface="Concert One"/>
+              </a:rPr>
+              <a:t>menentukan</a:t>
+            </a:r>
+            <a:r>
+              <a:rPr lang="en-US" sz="5400" b="1" i="0" u="none" strike="noStrike" cap="none" dirty="0">
+                <a:solidFill>
+                  <a:srgbClr val="000000"/>
+                </a:solidFill>
+                <a:latin typeface="Concert One"/>
+                <a:ea typeface="Concert One"/>
+                <a:cs typeface="Concert One"/>
+                <a:sym typeface="Concert One"/>
+              </a:rPr>
+              <a:t> “</a:t>
+            </a:r>
+            <a:r>
+              <a:rPr lang="en-US" sz="5400" b="1" i="0" u="none" strike="noStrike" cap="none" dirty="0" err="1">
+                <a:solidFill>
+                  <a:srgbClr val="000000"/>
+                </a:solidFill>
+                <a:latin typeface="Concert One"/>
+                <a:ea typeface="Concert One"/>
+                <a:cs typeface="Concert One"/>
+                <a:sym typeface="Concert One"/>
+              </a:rPr>
+              <a:t>siapa</a:t>
+            </a:r>
+            <a:r>
+              <a:rPr lang="en-US" sz="5400" b="1" i="0" u="none" strike="noStrike" cap="none" dirty="0">
+                <a:solidFill>
+                  <a:srgbClr val="000000"/>
+                </a:solidFill>
+                <a:latin typeface="Concert One"/>
+                <a:ea typeface="Concert One"/>
+                <a:cs typeface="Concert One"/>
+                <a:sym typeface="Concert One"/>
+              </a:rPr>
+              <a:t> </a:t>
+            </a:r>
+            <a:r>
+              <a:rPr lang="en-US" sz="5400" b="1" i="0" u="none" strike="noStrike" cap="none" dirty="0" err="1">
+                <a:solidFill>
+                  <a:srgbClr val="000000"/>
+                </a:solidFill>
+                <a:latin typeface="Concert One"/>
+                <a:ea typeface="Concert One"/>
+                <a:cs typeface="Concert One"/>
+                <a:sym typeface="Concert One"/>
+              </a:rPr>
+              <a:t>bisa</a:t>
+            </a:r>
+            <a:r>
+              <a:rPr lang="en-US" sz="5400" b="1" i="0" u="none" strike="noStrike" cap="none" dirty="0">
+                <a:solidFill>
+                  <a:srgbClr val="000000"/>
+                </a:solidFill>
+                <a:latin typeface="Concert One"/>
+                <a:ea typeface="Concert One"/>
+                <a:cs typeface="Concert One"/>
+                <a:sym typeface="Concert One"/>
+              </a:rPr>
+              <a:t> </a:t>
+            </a:r>
+            <a:r>
+              <a:rPr lang="en-US" sz="5400" b="1" i="0" u="none" strike="noStrike" cap="none" dirty="0" err="1">
+                <a:solidFill>
+                  <a:srgbClr val="000000"/>
+                </a:solidFill>
+                <a:latin typeface="Concert One"/>
+                <a:ea typeface="Concert One"/>
+                <a:cs typeface="Concert One"/>
+                <a:sym typeface="Concert One"/>
+              </a:rPr>
+              <a:t>melakukan</a:t>
+            </a:r>
+            <a:r>
+              <a:rPr lang="en-US" sz="5400" b="1" i="0" u="none" strike="noStrike" cap="none" dirty="0">
+                <a:solidFill>
+                  <a:srgbClr val="000000"/>
+                </a:solidFill>
+                <a:latin typeface="Concert One"/>
+                <a:ea typeface="Concert One"/>
+                <a:cs typeface="Concert One"/>
+                <a:sym typeface="Concert One"/>
+              </a:rPr>
+              <a:t> </a:t>
+            </a:r>
+            <a:r>
+              <a:rPr lang="en-US" sz="5400" b="1" i="0" u="none" strike="noStrike" cap="none" dirty="0" err="1">
+                <a:solidFill>
+                  <a:srgbClr val="000000"/>
+                </a:solidFill>
+                <a:latin typeface="Concert One"/>
+                <a:ea typeface="Concert One"/>
+                <a:cs typeface="Concert One"/>
+                <a:sym typeface="Concert One"/>
+              </a:rPr>
+              <a:t>apa</a:t>
+            </a:r>
+            <a:r>
+              <a:rPr lang="en-US" sz="5400" b="1" i="0" u="none" strike="noStrike" cap="none" dirty="0">
+                <a:solidFill>
+                  <a:srgbClr val="000000"/>
+                </a:solidFill>
+                <a:latin typeface="Concert One"/>
+                <a:ea typeface="Concert One"/>
+                <a:cs typeface="Concert One"/>
+                <a:sym typeface="Concert One"/>
+              </a:rPr>
+              <a:t> di </a:t>
+            </a:r>
+            <a:r>
+              <a:rPr lang="en-US" sz="5400" b="1" i="0" u="none" strike="noStrike" cap="none" dirty="0" err="1">
+                <a:solidFill>
+                  <a:srgbClr val="000000"/>
+                </a:solidFill>
+                <a:latin typeface="Concert One"/>
+                <a:ea typeface="Concert One"/>
+                <a:cs typeface="Concert One"/>
+                <a:sym typeface="Concert One"/>
+              </a:rPr>
+              <a:t>dalam</a:t>
+            </a:r>
+            <a:r>
+              <a:rPr lang="en-US" sz="5400" b="1" i="0" u="none" strike="noStrike" cap="none" dirty="0">
+                <a:solidFill>
+                  <a:srgbClr val="000000"/>
+                </a:solidFill>
+                <a:latin typeface="Concert One"/>
+                <a:ea typeface="Concert One"/>
+                <a:cs typeface="Concert One"/>
+                <a:sym typeface="Concert One"/>
+              </a:rPr>
+              <a:t> </a:t>
+            </a:r>
+            <a:r>
+              <a:rPr lang="en-US" sz="5400" b="1" i="0" u="none" strike="noStrike" cap="none" dirty="0" err="1">
+                <a:solidFill>
+                  <a:srgbClr val="000000"/>
+                </a:solidFill>
+                <a:latin typeface="Concert One"/>
+                <a:ea typeface="Concert One"/>
+                <a:cs typeface="Concert One"/>
+                <a:sym typeface="Concert One"/>
+              </a:rPr>
+              <a:t>sistem</a:t>
+            </a:r>
+            <a:r>
+              <a:rPr lang="en-US" sz="5400" b="1" i="0" u="none" strike="noStrike" cap="none" dirty="0">
+                <a:solidFill>
+                  <a:srgbClr val="000000"/>
+                </a:solidFill>
+                <a:latin typeface="Concert One"/>
+                <a:ea typeface="Concert One"/>
+                <a:cs typeface="Concert One"/>
+                <a:sym typeface="Concert One"/>
+              </a:rPr>
+              <a:t>”.</a:t>
+            </a:r>
+            <a:endParaRPr sz="5400" b="1" dirty="0">
+              <a:latin typeface="Concert One"/>
+              <a:ea typeface="Concert One"/>
+              <a:cs typeface="Concert One"/>
+              <a:sym typeface="Concert One"/>
+            </a:endParaRPr>
+          </a:p>
+        </p:txBody>
+      </p:sp>
+      <p:sp>
+        <p:nvSpPr>
+          <p:cNvPr id="166" name="Google Shape;166;p13">
+            <a:extLst>
+              <a:ext uri="{FF2B5EF4-FFF2-40B4-BE49-F238E27FC236}">
+                <a16:creationId xmlns:a16="http://schemas.microsoft.com/office/drawing/2014/main" id="{768D6A19-BC2B-5B52-3887-47F0F64D45C9}"/>
+              </a:ext>
+            </a:extLst>
+          </p:cNvPr>
+          <p:cNvSpPr txBox="1"/>
+          <p:nvPr/>
+        </p:nvSpPr>
+        <p:spPr>
+          <a:xfrm>
+            <a:off x="6074190" y="2252329"/>
+            <a:ext cx="6139620" cy="369332"/>
+          </a:xfrm>
+          <a:prstGeom prst="rect">
+            <a:avLst/>
+          </a:prstGeom>
+          <a:noFill/>
+          <a:ln>
+            <a:noFill/>
+          </a:ln>
+        </p:spPr>
+        <p:txBody>
+          <a:bodyPr spcFirstLastPara="1" wrap="square" lIns="0" tIns="0" rIns="0" bIns="0" anchor="t" anchorCtr="0">
+            <a:spAutoFit/>
+          </a:bodyPr>
+          <a:lstStyle/>
+          <a:p>
+            <a:pPr marL="0" marR="0" lvl="0" indent="0" algn="ctr" rtl="0">
+              <a:lnSpc>
+                <a:spcPct val="80000"/>
+              </a:lnSpc>
+              <a:spcBef>
+                <a:spcPts val="0"/>
+              </a:spcBef>
+              <a:spcAft>
+                <a:spcPts val="0"/>
+              </a:spcAft>
+              <a:buNone/>
+            </a:pPr>
+            <a:r>
+              <a:rPr lang="en-US" sz="3000" i="0" u="none" strike="noStrike" cap="none" dirty="0" err="1">
+                <a:solidFill>
+                  <a:srgbClr val="000000"/>
+                </a:solidFill>
+                <a:latin typeface="Concert One"/>
+                <a:ea typeface="Concert One"/>
+                <a:cs typeface="Concert One"/>
+                <a:sym typeface="Concert One"/>
+              </a:rPr>
+              <a:t>Membuat</a:t>
+            </a:r>
+            <a:r>
+              <a:rPr lang="en-US" sz="3000" i="0" u="none" strike="noStrike" cap="none" dirty="0">
+                <a:solidFill>
+                  <a:srgbClr val="000000"/>
+                </a:solidFill>
+                <a:latin typeface="Concert One"/>
+                <a:ea typeface="Concert One"/>
+                <a:cs typeface="Concert One"/>
+                <a:sym typeface="Concert One"/>
+              </a:rPr>
+              <a:t> Use Case Diagram  </a:t>
+            </a:r>
+            <a:endParaRPr dirty="0">
+              <a:latin typeface="Concert One"/>
+              <a:ea typeface="Concert One"/>
+              <a:cs typeface="Concert One"/>
+              <a:sym typeface="Concert One"/>
+            </a:endParaRPr>
+          </a:p>
+        </p:txBody>
+      </p:sp>
+    </p:spTree>
+    <p:extLst>
+      <p:ext uri="{BB962C8B-B14F-4D97-AF65-F5344CB8AC3E}">
+        <p14:creationId xmlns:p14="http://schemas.microsoft.com/office/powerpoint/2010/main" val="2230254669"/>
+      </p:ext>
+    </p:extLst>
+  </p:cSld>
+  <p:clrMapOvr>
+    <a:masterClrMapping/>
+  </p:clrMapOvr>
+</p:sld>
+</file>
+
+<file path=ppt/slides/slide15.xml><?xml version="1.0" encoding="utf-8"?>
+<p:sld xmlns:a="http://schemas.openxmlformats.org/drawingml/2006/main" xmlns:r="http://schemas.openxmlformats.org/officeDocument/2006/relationships" xmlns:p="http://schemas.openxmlformats.org/presentationml/2006/main">
+  <p:cSld>
+    <p:bg>
+      <p:bgPr>
+        <a:solidFill>
+          <a:srgbClr val="43D374"/>
+        </a:solidFill>
+        <a:effectLst/>
+      </p:bgPr>
+    </p:bg>
+    <p:spTree>
+      <p:nvGrpSpPr>
+        <p:cNvPr id="1" name="Shape 328">
+          <a:extLst>
+            <a:ext uri="{FF2B5EF4-FFF2-40B4-BE49-F238E27FC236}">
+              <a16:creationId xmlns:a16="http://schemas.microsoft.com/office/drawing/2014/main" id="{790787FD-E7E5-B41C-F67E-3FBFC0E285A0}"/>
+            </a:ext>
+          </a:extLst>
+        </p:cNvPr>
+        <p:cNvGrpSpPr/>
+        <p:nvPr/>
+      </p:nvGrpSpPr>
+      <p:grpSpPr>
+        <a:xfrm>
+          <a:off x="0" y="0"/>
+          <a:ext cx="0" cy="0"/>
+          <a:chOff x="0" y="0"/>
+          <a:chExt cx="0" cy="0"/>
+        </a:xfrm>
+      </p:grpSpPr>
+      <p:grpSp>
+        <p:nvGrpSpPr>
+          <p:cNvPr id="329" name="Google Shape;329;p19">
+            <a:extLst>
+              <a:ext uri="{FF2B5EF4-FFF2-40B4-BE49-F238E27FC236}">
+                <a16:creationId xmlns:a16="http://schemas.microsoft.com/office/drawing/2014/main" id="{62DAA932-FAE4-4A16-5299-4A352C4508B8}"/>
+              </a:ext>
+            </a:extLst>
+          </p:cNvPr>
+          <p:cNvGrpSpPr/>
+          <p:nvPr/>
+        </p:nvGrpSpPr>
+        <p:grpSpPr>
+          <a:xfrm>
+            <a:off x="675774" y="0"/>
+            <a:ext cx="7829550" cy="2190072"/>
+            <a:chOff x="0" y="-47625"/>
+            <a:chExt cx="2244026" cy="627696"/>
+          </a:xfrm>
+        </p:grpSpPr>
+        <p:sp>
+          <p:nvSpPr>
+            <p:cNvPr id="330" name="Google Shape;330;p19">
+              <a:extLst>
+                <a:ext uri="{FF2B5EF4-FFF2-40B4-BE49-F238E27FC236}">
+                  <a16:creationId xmlns:a16="http://schemas.microsoft.com/office/drawing/2014/main" id="{394E03BE-870D-396F-B803-F296449DE26F}"/>
+                </a:ext>
+              </a:extLst>
+            </p:cNvPr>
+            <p:cNvSpPr/>
+            <p:nvPr/>
+          </p:nvSpPr>
+          <p:spPr>
+            <a:xfrm>
+              <a:off x="0" y="0"/>
+              <a:ext cx="2244026" cy="580071"/>
+            </a:xfrm>
+            <a:custGeom>
+              <a:avLst/>
+              <a:gdLst/>
+              <a:ahLst/>
+              <a:cxnLst/>
+              <a:rect l="l" t="t" r="r" b="b"/>
+              <a:pathLst>
+                <a:path w="2244026" h="580071" extrusionOk="0">
+                  <a:moveTo>
+                    <a:pt x="29664" y="0"/>
+                  </a:moveTo>
+                  <a:lnTo>
+                    <a:pt x="2214362" y="0"/>
+                  </a:lnTo>
+                  <a:cubicBezTo>
+                    <a:pt x="2222229" y="0"/>
+                    <a:pt x="2229774" y="3125"/>
+                    <a:pt x="2235338" y="8688"/>
+                  </a:cubicBezTo>
+                  <a:cubicBezTo>
+                    <a:pt x="2240901" y="14252"/>
+                    <a:pt x="2244026" y="21797"/>
+                    <a:pt x="2244026" y="29664"/>
+                  </a:cubicBezTo>
+                  <a:lnTo>
+                    <a:pt x="2244026" y="550407"/>
+                  </a:lnTo>
+                  <a:cubicBezTo>
+                    <a:pt x="2244026" y="558274"/>
+                    <a:pt x="2240901" y="565820"/>
+                    <a:pt x="2235338" y="571383"/>
+                  </a:cubicBezTo>
+                  <a:cubicBezTo>
+                    <a:pt x="2229774" y="576946"/>
+                    <a:pt x="2222229" y="580071"/>
+                    <a:pt x="2214362" y="580071"/>
+                  </a:cubicBezTo>
+                  <a:lnTo>
+                    <a:pt x="29664" y="580071"/>
+                  </a:lnTo>
+                  <a:cubicBezTo>
+                    <a:pt x="21797" y="580071"/>
+                    <a:pt x="14252" y="576946"/>
+                    <a:pt x="8688" y="571383"/>
+                  </a:cubicBezTo>
+                  <a:cubicBezTo>
+                    <a:pt x="3125" y="565820"/>
+                    <a:pt x="0" y="558274"/>
+                    <a:pt x="0" y="550407"/>
+                  </a:cubicBezTo>
+                  <a:lnTo>
+                    <a:pt x="0" y="29664"/>
+                  </a:lnTo>
+                  <a:cubicBezTo>
+                    <a:pt x="0" y="21797"/>
+                    <a:pt x="3125" y="14252"/>
+                    <a:pt x="8688" y="8688"/>
+                  </a:cubicBezTo>
+                  <a:cubicBezTo>
+                    <a:pt x="14252" y="3125"/>
+                    <a:pt x="21797" y="0"/>
+                    <a:pt x="29664" y="0"/>
+                  </a:cubicBezTo>
+                  <a:close/>
+                </a:path>
+              </a:pathLst>
+            </a:custGeom>
+            <a:solidFill>
+              <a:srgbClr val="7FDAFF"/>
+            </a:solidFill>
+            <a:ln w="85725" cap="rnd" cmpd="sng">
+              <a:solidFill>
+                <a:srgbClr val="000000"/>
+              </a:solidFill>
+              <a:prstDash val="solid"/>
+              <a:round/>
+              <a:headEnd type="none" w="sm" len="sm"/>
+              <a:tailEnd type="none" w="sm" len="sm"/>
+            </a:ln>
+          </p:spPr>
+          <p:txBody>
+            <a:bodyPr spcFirstLastPara="1" wrap="square" lIns="91425" tIns="91425" rIns="91425" bIns="91425" anchor="ctr" anchorCtr="0">
+              <a:noAutofit/>
+            </a:bodyPr>
+            <a:lstStyle/>
+            <a:p>
+              <a:pPr marL="0" lvl="0" indent="0" algn="l" rtl="0">
+                <a:spcBef>
+                  <a:spcPts val="0"/>
+                </a:spcBef>
+                <a:spcAft>
+                  <a:spcPts val="0"/>
+                </a:spcAft>
+                <a:buNone/>
+              </a:pPr>
+              <a:endParaRPr/>
+            </a:p>
+          </p:txBody>
+        </p:sp>
+        <p:sp>
+          <p:nvSpPr>
+            <p:cNvPr id="331" name="Google Shape;331;p19">
+              <a:extLst>
+                <a:ext uri="{FF2B5EF4-FFF2-40B4-BE49-F238E27FC236}">
+                  <a16:creationId xmlns:a16="http://schemas.microsoft.com/office/drawing/2014/main" id="{D87A8710-C253-7268-0EE0-3BF7347F00AC}"/>
+                </a:ext>
+              </a:extLst>
+            </p:cNvPr>
+            <p:cNvSpPr txBox="1"/>
+            <p:nvPr/>
+          </p:nvSpPr>
+          <p:spPr>
+            <a:xfrm>
+              <a:off x="0" y="-47625"/>
+              <a:ext cx="2244026" cy="627696"/>
+            </a:xfrm>
+            <a:prstGeom prst="rect">
+              <a:avLst/>
+            </a:prstGeom>
+            <a:noFill/>
+            <a:ln>
+              <a:noFill/>
+            </a:ln>
+          </p:spPr>
+          <p:txBody>
+            <a:bodyPr spcFirstLastPara="1" wrap="square" lIns="50800" tIns="50800" rIns="50800" bIns="50800" anchor="ctr" anchorCtr="0">
+              <a:noAutofit/>
+            </a:bodyPr>
+            <a:lstStyle/>
+            <a:p>
+              <a:pPr marL="0" marR="0" lvl="0" indent="0" algn="ctr" rtl="0">
+                <a:lnSpc>
+                  <a:spcPct val="186611"/>
+                </a:lnSpc>
+                <a:spcBef>
+                  <a:spcPts val="0"/>
+                </a:spcBef>
+                <a:spcAft>
+                  <a:spcPts val="0"/>
+                </a:spcAft>
+                <a:buNone/>
+              </a:pPr>
+              <a:endParaRPr sz="1800" b="0" i="0" u="none" strike="noStrike" cap="none">
+                <a:solidFill>
+                  <a:schemeClr val="dk1"/>
+                </a:solidFill>
+                <a:latin typeface="Calibri"/>
+                <a:ea typeface="Calibri"/>
+                <a:cs typeface="Calibri"/>
+                <a:sym typeface="Calibri"/>
+              </a:endParaRPr>
+            </a:p>
+          </p:txBody>
+        </p:sp>
+      </p:grpSp>
+      <p:sp>
+        <p:nvSpPr>
+          <p:cNvPr id="359" name="Google Shape;359;p19">
+            <a:extLst>
+              <a:ext uri="{FF2B5EF4-FFF2-40B4-BE49-F238E27FC236}">
+                <a16:creationId xmlns:a16="http://schemas.microsoft.com/office/drawing/2014/main" id="{182DC009-A828-A23B-311B-71A1C6252B18}"/>
+              </a:ext>
+            </a:extLst>
+          </p:cNvPr>
+          <p:cNvSpPr txBox="1"/>
+          <p:nvPr/>
+        </p:nvSpPr>
+        <p:spPr>
+          <a:xfrm>
+            <a:off x="801265" y="716454"/>
+            <a:ext cx="7578568" cy="923330"/>
+          </a:xfrm>
+          <a:prstGeom prst="rect">
+            <a:avLst/>
+          </a:prstGeom>
+          <a:noFill/>
+          <a:ln>
+            <a:noFill/>
+          </a:ln>
+        </p:spPr>
+        <p:txBody>
+          <a:bodyPr spcFirstLastPara="1" wrap="square" lIns="0" tIns="0" rIns="0" bIns="0" anchor="t" anchorCtr="0">
+            <a:spAutoFit/>
+          </a:bodyPr>
+          <a:lstStyle/>
+          <a:p>
+            <a:pPr marL="0" marR="0" lvl="0" indent="0" algn="ctr" rtl="0">
+              <a:lnSpc>
+                <a:spcPct val="80000"/>
+              </a:lnSpc>
+              <a:spcBef>
+                <a:spcPts val="0"/>
+              </a:spcBef>
+              <a:spcAft>
+                <a:spcPts val="0"/>
+              </a:spcAft>
+              <a:buNone/>
+            </a:pPr>
+            <a:r>
+              <a:rPr lang="en-US" sz="7500" i="0" u="none" strike="noStrike" cap="none" dirty="0" err="1">
+                <a:solidFill>
+                  <a:srgbClr val="000000"/>
+                </a:solidFill>
+                <a:latin typeface="Concert One"/>
+                <a:ea typeface="Concert One"/>
+                <a:cs typeface="Concert One"/>
+                <a:sym typeface="Concert One"/>
+              </a:rPr>
+              <a:t>Catatan</a:t>
+            </a:r>
+            <a:r>
+              <a:rPr lang="en-US" sz="7500" i="0" u="none" strike="noStrike" cap="none" dirty="0">
+                <a:solidFill>
+                  <a:srgbClr val="000000"/>
+                </a:solidFill>
+                <a:latin typeface="Concert One"/>
+                <a:ea typeface="Concert One"/>
+                <a:cs typeface="Concert One"/>
+                <a:sym typeface="Concert One"/>
+              </a:rPr>
+              <a:t> </a:t>
+            </a:r>
+            <a:r>
+              <a:rPr lang="en-US" sz="7500" i="0" u="none" strike="noStrike" cap="none" dirty="0" err="1">
+                <a:solidFill>
+                  <a:srgbClr val="000000"/>
+                </a:solidFill>
+                <a:latin typeface="Concert One"/>
+                <a:ea typeface="Concert One"/>
+                <a:cs typeface="Concert One"/>
+                <a:sym typeface="Concert One"/>
+              </a:rPr>
+              <a:t>Tahap</a:t>
+            </a:r>
+            <a:r>
+              <a:rPr lang="en-US" sz="7500" i="0" u="none" strike="noStrike" cap="none" dirty="0">
+                <a:solidFill>
+                  <a:srgbClr val="000000"/>
+                </a:solidFill>
+                <a:latin typeface="Concert One"/>
+                <a:ea typeface="Concert One"/>
+                <a:cs typeface="Concert One"/>
+                <a:sym typeface="Concert One"/>
+              </a:rPr>
+              <a:t> 1.4</a:t>
+            </a:r>
+            <a:endParaRPr dirty="0">
+              <a:latin typeface="Concert One"/>
+              <a:ea typeface="Concert One"/>
+              <a:cs typeface="Concert One"/>
+              <a:sym typeface="Concert One"/>
+            </a:endParaRPr>
+          </a:p>
+        </p:txBody>
+      </p:sp>
+      <p:pic>
+        <p:nvPicPr>
+          <p:cNvPr id="5" name="Picture Placeholder 3">
+            <a:extLst>
+              <a:ext uri="{FF2B5EF4-FFF2-40B4-BE49-F238E27FC236}">
+                <a16:creationId xmlns:a16="http://schemas.microsoft.com/office/drawing/2014/main" id="{C1D75E1F-3479-641C-01F2-9D00D86937DB}"/>
+              </a:ext>
+            </a:extLst>
+          </p:cNvPr>
+          <p:cNvPicPr preferRelativeResize="0">
+            <a:picLocks noChangeAspect="1"/>
+          </p:cNvPicPr>
+          <p:nvPr/>
+        </p:nvPicPr>
+        <p:blipFill>
+          <a:blip r:embed="rId3"/>
+          <a:stretch>
+            <a:fillRect/>
+          </a:stretch>
+        </p:blipFill>
+        <p:spPr>
+          <a:xfrm>
+            <a:off x="1744255" y="2356239"/>
+            <a:ext cx="15035786" cy="7711332"/>
+          </a:xfrm>
+          <a:prstGeom prst="roundRect">
+            <a:avLst>
+              <a:gd name="adj" fmla="val 2690"/>
+            </a:avLst>
+          </a:prstGeom>
+          <a:noFill/>
+          <a:ln w="76200" cap="flat" cmpd="sng">
+            <a:solidFill>
+              <a:srgbClr val="000000"/>
+            </a:solidFill>
+            <a:prstDash val="solid"/>
+            <a:round/>
+            <a:headEnd type="none" w="sm" len="sm"/>
+            <a:tailEnd type="none" w="sm" len="sm"/>
+          </a:ln>
+        </p:spPr>
+      </p:pic>
+    </p:spTree>
+    <p:extLst>
+      <p:ext uri="{BB962C8B-B14F-4D97-AF65-F5344CB8AC3E}">
+        <p14:creationId xmlns:p14="http://schemas.microsoft.com/office/powerpoint/2010/main" val="2811351807"/>
+      </p:ext>
+    </p:extLst>
+  </p:cSld>
+  <p:clrMapOvr>
+    <a:masterClrMapping/>
+  </p:clrMapOvr>
+</p:sld>
+</file>
+
+<file path=ppt/slides/slide16.xml><?xml version="1.0" encoding="utf-8"?>
+<p:sld xmlns:a="http://schemas.openxmlformats.org/drawingml/2006/main" xmlns:r="http://schemas.openxmlformats.org/officeDocument/2006/relationships" xmlns:p="http://schemas.openxmlformats.org/presentationml/2006/main">
+  <p:cSld>
+    <p:spTree>
+      <p:nvGrpSpPr>
+        <p:cNvPr id="1" name=""/>
+        <p:cNvGrpSpPr/>
+        <p:nvPr/>
+      </p:nvGrpSpPr>
+      <p:grpSpPr>
+        <a:xfrm>
+          <a:off x="0" y="0"/>
+          <a:ext cx="0" cy="0"/>
+          <a:chOff x="0" y="0"/>
+          <a:chExt cx="0" cy="0"/>
+        </a:xfrm>
+      </p:grpSpPr>
+      <p:pic>
+        <p:nvPicPr>
+          <p:cNvPr id="4" name="Picture Placeholder 3">
+            <a:extLst>
+              <a:ext uri="{FF2B5EF4-FFF2-40B4-BE49-F238E27FC236}">
+                <a16:creationId xmlns:a16="http://schemas.microsoft.com/office/drawing/2014/main" id="{31AFA539-F3AD-EC32-D4D9-B5C835214361}"/>
+              </a:ext>
+            </a:extLst>
+          </p:cNvPr>
+          <p:cNvPicPr preferRelativeResize="0">
+            <a:picLocks noGrp="1" noChangeAspect="1"/>
+          </p:cNvPicPr>
+          <p:nvPr>
+            <p:ph type="pic" idx="2"/>
+          </p:nvPr>
+        </p:nvPicPr>
+        <p:blipFill>
+          <a:blip r:embed="rId2"/>
+          <a:stretch>
+            <a:fillRect/>
+          </a:stretch>
+        </p:blipFill>
+        <p:spPr>
+          <a:xfrm>
+            <a:off x="9144000" y="2301200"/>
+            <a:ext cx="8637358" cy="4429800"/>
+          </a:xfrm>
+          <a:prstGeom prst="roundRect">
+            <a:avLst>
+              <a:gd name="adj" fmla="val 2690"/>
+            </a:avLst>
+          </a:prstGeom>
+          <a:noFill/>
+          <a:ln w="76200" cap="flat" cmpd="sng">
+            <a:solidFill>
+              <a:srgbClr val="000000"/>
+            </a:solidFill>
+            <a:prstDash val="solid"/>
+            <a:round/>
+            <a:headEnd type="none" w="sm" len="sm"/>
+            <a:tailEnd type="none" w="sm" len="sm"/>
+          </a:ln>
+        </p:spPr>
+      </p:pic>
+    </p:spTree>
+    <p:extLst>
+      <p:ext uri="{BB962C8B-B14F-4D97-AF65-F5344CB8AC3E}">
+        <p14:creationId xmlns:p14="http://schemas.microsoft.com/office/powerpoint/2010/main" val="2751306968"/>
       </p:ext>
     </p:extLst>
   </p:cSld>

</xml_diff>